<commit_message>
Update Fig 3 (reduce 7-obs window stopping at t0) and Fig 4
</commit_message>
<xml_diff>
--- a/report/illustrations/swisstopo_continuous_updated.pptx
+++ b/report/illustrations/swisstopo_continuous_updated.pptx
@@ -33793,7 +33793,7 @@
             <p:spPr>
               <a:xfrm>
                 <a:off x="172800" y="2415959"/>
-                <a:ext cx="8377434" cy="1472053"/>
+                <a:ext cx="7730229" cy="1472053"/>
               </a:xfrm>
               <a:prstGeom prst="rect">
                 <a:avLst/>
@@ -35976,7 +35976,7 @@
           <p:spPr>
             <a:xfrm>
               <a:off x="173737" y="862745"/>
-              <a:ext cx="8388372" cy="1472053"/>
+              <a:ext cx="7745617" cy="1472053"/>
             </a:xfrm>
             <a:prstGeom prst="rect">
               <a:avLst/>
@@ -37605,14 +37605,14 @@
             </a:ln>
           </p:spPr>
           <p:txBody>
-            <a:bodyPr spcFirstLastPara="1" wrap="square" lIns="55550" tIns="27775" rIns="55550" bIns="27775" anchor="ctr" anchorCtr="0">
+            <a:bodyPr spcFirstLastPara="1" wrap="square" lIns="0" tIns="0" rIns="0" bIns="0" anchor="ctr" anchorCtr="0">
               <a:noAutofit/>
             </a:bodyPr>
             <a:lstStyle/>
             <a:p>
               <a:pPr lvl="0" algn="ctr"/>
               <a:r>
-                <a:rPr lang="en-US" sz="800" dirty="0">
+                <a:rPr lang="en-US" sz="850" dirty="0">
                   <a:solidFill>
                     <a:schemeClr val="lt1"/>
                   </a:solidFill>
@@ -38536,7 +38536,7 @@
             </a:ln>
           </p:spPr>
           <p:txBody>
-            <a:bodyPr spcFirstLastPara="1" wrap="square" lIns="55550" tIns="27775" rIns="55550" bIns="27775" anchor="ctr" anchorCtr="0">
+            <a:bodyPr spcFirstLastPara="1" wrap="square" lIns="0" tIns="0" rIns="0" bIns="0" anchor="ctr" anchorCtr="0">
               <a:noAutofit/>
             </a:bodyPr>
             <a:lstStyle/>
@@ -38551,7 +38551,7 @@
                 <a:buNone/>
               </a:pPr>
               <a:r>
-                <a:rPr lang="en-US" sz="700" dirty="0">
+                <a:rPr lang="en-US" sz="1000" dirty="0">
                   <a:solidFill>
                     <a:schemeClr val="lt1"/>
                   </a:solidFill>
@@ -38562,7 +38562,7 @@
                 </a:rPr>
                 <a:t>(outlier)</a:t>
               </a:r>
-              <a:endParaRPr sz="700" dirty="0">
+              <a:endParaRPr sz="1000" dirty="0">
                 <a:solidFill>
                   <a:schemeClr val="lt1"/>
                 </a:solidFill>

</xml_diff>